<commit_message>
wavelet diagnostics and updated parameters
</commit_message>
<xml_diff>
--- a/NO_2D_metamaterials_summary.pptx
+++ b/NO_2D_metamaterials_summary.pptx
@@ -5,13 +5,15 @@
     <p:sldMasterId id="2147483660" r:id="rId4"/>
   </p:sldMasterIdLst>
   <p:notesMasterIdLst>
-    <p:notesMasterId r:id="rId9"/>
+    <p:notesMasterId r:id="rId11"/>
   </p:notesMasterIdLst>
   <p:sldIdLst>
     <p:sldId id="256" r:id="rId5"/>
-    <p:sldId id="918" r:id="rId6"/>
-    <p:sldId id="1028" r:id="rId7"/>
-    <p:sldId id="1024" r:id="rId8"/>
+    <p:sldId id="1030" r:id="rId6"/>
+    <p:sldId id="1029" r:id="rId7"/>
+    <p:sldId id="918" r:id="rId8"/>
+    <p:sldId id="1028" r:id="rId9"/>
+    <p:sldId id="1024" r:id="rId10"/>
   </p:sldIdLst>
   <p:sldSz cx="12192000" cy="6858000"/>
   <p:notesSz cx="6858000" cy="9144000"/>
@@ -116,6 +118,8 @@
         <p14:section name="Intro" id="{8504F1F5-CE46-42C0-85B0-35D241E81344}">
           <p14:sldIdLst>
             <p14:sldId id="256"/>
+            <p14:sldId id="1030"/>
+            <p14:sldId id="1029"/>
             <p14:sldId id="918"/>
             <p14:sldId id="1028"/>
             <p14:sldId id="1024"/>
@@ -218,7 +222,7 @@
           <a:p>
             <a:fld id="{5B2A9559-5325-4FFA-A5F2-CBDDB1074751}" type="datetimeFigureOut">
               <a:rPr lang="en-US" smtClean="0"/>
-              <a:t>3/25/2024</a:t>
+              <a:t>26/06/12</a:t>
             </a:fld>
             <a:endParaRPr lang="en-US"/>
           </a:p>
@@ -559,6 +563,90 @@
     </p:spTree>
     <p:extLst>
       <p:ext uri="{BB962C8B-B14F-4D97-AF65-F5344CB8AC3E}">
+        <p14:creationId xmlns:p14="http://schemas.microsoft.com/office/powerpoint/2010/main" val="1922739606"/>
+      </p:ext>
+    </p:extLst>
+  </p:cSld>
+  <p:clrMapOvr>
+    <a:masterClrMapping/>
+  </p:clrMapOvr>
+</p:notes>
+</file>
+
+<file path=ppt/notesSlides/notesSlide2.xml><?xml version="1.0" encoding="utf-8"?>
+<p:notes xmlns:a="http://schemas.openxmlformats.org/drawingml/2006/main" xmlns:r="http://schemas.openxmlformats.org/officeDocument/2006/relationships" xmlns:p="http://schemas.openxmlformats.org/presentationml/2006/main">
+  <p:cSld>
+    <p:spTree>
+      <p:nvGrpSpPr>
+        <p:cNvPr id="1" name=""/>
+        <p:cNvGrpSpPr/>
+        <p:nvPr/>
+      </p:nvGrpSpPr>
+      <p:grpSpPr>
+        <a:xfrm>
+          <a:off x="0" y="0"/>
+          <a:ext cx="0" cy="0"/>
+          <a:chOff x="0" y="0"/>
+          <a:chExt cx="0" cy="0"/>
+        </a:xfrm>
+      </p:grpSpPr>
+      <p:sp>
+        <p:nvSpPr>
+          <p:cNvPr id="2" name="Slide Image Placeholder 1"/>
+          <p:cNvSpPr>
+            <a:spLocks noGrp="1" noRot="1" noChangeAspect="1"/>
+          </p:cNvSpPr>
+          <p:nvPr>
+            <p:ph type="sldImg"/>
+          </p:nvPr>
+        </p:nvSpPr>
+        <p:spPr/>
+      </p:sp>
+      <p:sp>
+        <p:nvSpPr>
+          <p:cNvPr id="3" name="Notes Placeholder 2"/>
+          <p:cNvSpPr>
+            <a:spLocks noGrp="1"/>
+          </p:cNvSpPr>
+          <p:nvPr>
+            <p:ph type="body" idx="1"/>
+          </p:nvPr>
+        </p:nvSpPr>
+        <p:spPr/>
+        <p:txBody>
+          <a:bodyPr/>
+          <a:lstStyle/>
+          <a:p>
+            <a:endParaRPr lang="en-US" dirty="0"/>
+          </a:p>
+        </p:txBody>
+      </p:sp>
+      <p:sp>
+        <p:nvSpPr>
+          <p:cNvPr id="4" name="Slide Number Placeholder 3"/>
+          <p:cNvSpPr>
+            <a:spLocks noGrp="1"/>
+          </p:cNvSpPr>
+          <p:nvPr>
+            <p:ph type="sldNum" sz="quarter" idx="5"/>
+          </p:nvPr>
+        </p:nvSpPr>
+        <p:spPr/>
+        <p:txBody>
+          <a:bodyPr/>
+          <a:lstStyle/>
+          <a:p>
+            <a:fld id="{5ED6D2F6-D9A8-4EC3-B74F-DA40A0FC4A95}" type="slidenum">
+              <a:rPr lang="en-US" smtClean="0"/>
+              <a:t>6</a:t>
+            </a:fld>
+            <a:endParaRPr lang="en-US"/>
+          </a:p>
+        </p:txBody>
+      </p:sp>
+    </p:spTree>
+    <p:extLst>
+      <p:ext uri="{BB962C8B-B14F-4D97-AF65-F5344CB8AC3E}">
         <p14:creationId xmlns:p14="http://schemas.microsoft.com/office/powerpoint/2010/main" val="1979914354"/>
       </p:ext>
     </p:extLst>
@@ -942,7 +1030,7 @@
           <a:p>
             <a:fld id="{43789B8F-7842-4BEF-9976-1EE74F57C738}" type="datetime1">
               <a:rPr lang="en-US" smtClean="0"/>
-              <a:t>3/25/2024</a:t>
+              <a:t>26/06/12</a:t>
             </a:fld>
             <a:endParaRPr lang="en-US"/>
           </a:p>
@@ -1174,7 +1262,7 @@
           <a:p>
             <a:fld id="{050F5937-DD26-4F95-A0ED-C31A278A1247}" type="datetime1">
               <a:rPr lang="en-US" smtClean="0"/>
-              <a:t>3/25/2024</a:t>
+              <a:t>26/06/12</a:t>
             </a:fld>
             <a:endParaRPr lang="en-US"/>
           </a:p>
@@ -1641,7 +1729,7 @@
           <a:p>
             <a:fld id="{49F581DC-F6E5-4AEE-98F3-A1977368E94D}" type="datetime1">
               <a:rPr lang="en-US" smtClean="0"/>
-              <a:t>3/25/2024</a:t>
+              <a:t>26/06/12</a:t>
             </a:fld>
             <a:endParaRPr lang="en-US"/>
           </a:p>
@@ -1961,7 +2049,7 @@
           <a:p>
             <a:fld id="{A23148C6-A681-474A-852B-6488E264F1FD}" type="datetime1">
               <a:rPr lang="en-US" smtClean="0"/>
-              <a:t>3/25/2024</a:t>
+              <a:t>26/06/12</a:t>
             </a:fld>
             <a:endParaRPr lang="en-US"/>
           </a:p>
@@ -2428,7 +2516,7 @@
           <a:p>
             <a:fld id="{E05877EE-87E6-4A80-A3D1-647EBC487900}" type="datetime1">
               <a:rPr lang="en-US" smtClean="0"/>
-              <a:t>3/25/2024</a:t>
+              <a:t>26/06/12</a:t>
             </a:fld>
             <a:endParaRPr lang="en-US"/>
           </a:p>
@@ -2958,7 +3046,7 @@
           <a:p>
             <a:fld id="{1F39E345-7F84-425C-B838-418A9624F210}" type="datetime1">
               <a:rPr lang="en-US" smtClean="0"/>
-              <a:t>3/25/2024</a:t>
+              <a:t>26/06/12</a:t>
             </a:fld>
             <a:endParaRPr lang="en-US"/>
           </a:p>
@@ -3273,7 +3361,7 @@
           <a:p>
             <a:fld id="{F90E5D04-5C5D-47CC-BDED-D4EAD1A4B7F8}" type="datetime1">
               <a:rPr lang="en-US" smtClean="0"/>
-              <a:t>3/25/2024</a:t>
+              <a:t>26/06/12</a:t>
             </a:fld>
             <a:endParaRPr lang="en-US"/>
           </a:p>
@@ -3621,7 +3709,7 @@
           <a:p>
             <a:fld id="{B019BD83-B2B4-4833-86B7-8D5583952E34}" type="datetime1">
               <a:rPr lang="en-US" smtClean="0"/>
-              <a:t>3/25/2024</a:t>
+              <a:t>26/06/12</a:t>
             </a:fld>
             <a:endParaRPr lang="en-US"/>
           </a:p>
@@ -4385,7 +4473,13 @@
   <p:cSld>
     <p:spTree>
       <p:nvGrpSpPr>
-        <p:cNvPr id="1" name=""/>
+        <p:cNvPr id="1" name="">
+          <a:extLst>
+            <a:ext uri="{FF2B5EF4-FFF2-40B4-BE49-F238E27FC236}">
+              <a16:creationId xmlns:a16="http://schemas.microsoft.com/office/drawing/2014/main" id="{B198D71B-9656-9696-4049-51CAB3907ACC}"/>
+            </a:ext>
+          </a:extLst>
+        </p:cNvPr>
         <p:cNvGrpSpPr/>
         <p:nvPr/>
       </p:nvGrpSpPr>
@@ -4402,7 +4496,7 @@
           <p:cNvPr id="2" name="Title 1">
             <a:extLst>
               <a:ext uri="{FF2B5EF4-FFF2-40B4-BE49-F238E27FC236}">
-                <a16:creationId xmlns:a16="http://schemas.microsoft.com/office/drawing/2014/main" id="{30C1DE39-28F2-E55C-A968-7BF5DE309FE2}"/>
+                <a16:creationId xmlns:a16="http://schemas.microsoft.com/office/drawing/2014/main" id="{AFE5BD1B-B3D2-6222-CF37-E6208E4199A7}"/>
               </a:ext>
             </a:extLst>
           </p:cNvPr>
@@ -4415,27 +4509,745 @@
         </p:nvSpPr>
         <p:spPr>
           <a:xfrm>
-            <a:off x="838200" y="90397"/>
-            <a:ext cx="10515600" cy="1056686"/>
-          </a:xfrm>
-        </p:spPr>
-        <p:txBody>
-          <a:bodyPr/>
+            <a:off x="838200" y="104608"/>
+            <a:ext cx="10515600" cy="783384"/>
+          </a:xfrm>
+        </p:spPr>
+        <p:txBody>
+          <a:bodyPr>
+            <a:normAutofit/>
+          </a:bodyPr>
           <a:lstStyle/>
           <a:p>
             <a:r>
-              <a:rPr lang="en-US" dirty="0"/>
-              <a:t>Motivation &amp; Applications</a:t>
-            </a:r>
-          </a:p>
-        </p:txBody>
-      </p:sp>
-      <p:sp>
-        <p:nvSpPr>
-          <p:cNvPr id="8" name="Content Placeholder 2">
-            <a:extLst>
-              <a:ext uri="{FF2B5EF4-FFF2-40B4-BE49-F238E27FC236}">
-                <a16:creationId xmlns:a16="http://schemas.microsoft.com/office/drawing/2014/main" id="{76E50227-F1D0-C0CB-9A2A-1A4DB4C8C040}"/>
+              <a:rPr lang="en-US" sz="4000" dirty="0"/>
+              <a:t>FNO Architecture &amp; Sample Example</a:t>
+            </a:r>
+          </a:p>
+        </p:txBody>
+      </p:sp>
+      <p:sp>
+        <p:nvSpPr>
+          <p:cNvPr id="12" name="TextBox 11">
+            <a:extLst>
+              <a:ext uri="{FF2B5EF4-FFF2-40B4-BE49-F238E27FC236}">
+                <a16:creationId xmlns:a16="http://schemas.microsoft.com/office/drawing/2014/main" id="{A98B73B6-016E-9EF0-F734-5E367E29DCF3}"/>
+              </a:ext>
+            </a:extLst>
+          </p:cNvPr>
+          <p:cNvSpPr txBox="1"/>
+          <p:nvPr/>
+        </p:nvSpPr>
+        <p:spPr>
+          <a:xfrm>
+            <a:off x="565244" y="2804616"/>
+            <a:ext cx="5423634" cy="246221"/>
+          </a:xfrm>
+          <a:prstGeom prst="rect">
+            <a:avLst/>
+          </a:prstGeom>
+          <a:noFill/>
+        </p:spPr>
+        <p:txBody>
+          <a:bodyPr wrap="square" rtlCol="0">
+            <a:spAutoFit/>
+          </a:bodyPr>
+          <a:lstStyle/>
+          <a:p>
+            <a:r>
+              <a:rPr lang="en-US" sz="1000" dirty="0" err="1"/>
+              <a:t>Kovachki</a:t>
+            </a:r>
+            <a:r>
+              <a:rPr lang="en-US" sz="1000" dirty="0"/>
+              <a:t> et. al: Neural Operator Learning Maps Between Function Spaces With Applications to PDEs</a:t>
+            </a:r>
+          </a:p>
+        </p:txBody>
+      </p:sp>
+      <p:pic>
+        <p:nvPicPr>
+          <p:cNvPr id="18" name="Content Placeholder 17" descr="A diagram of a machine&#10;&#10;Description automatically generated">
+            <a:extLst>
+              <a:ext uri="{FF2B5EF4-FFF2-40B4-BE49-F238E27FC236}">
+                <a16:creationId xmlns:a16="http://schemas.microsoft.com/office/drawing/2014/main" id="{3F40136D-F25E-4B45-1242-26DE7FD49FA8}"/>
+              </a:ext>
+            </a:extLst>
+          </p:cNvPr>
+          <p:cNvPicPr>
+            <a:picLocks noGrp="1" noChangeAspect="1"/>
+          </p:cNvPicPr>
+          <p:nvPr>
+            <p:ph idx="1"/>
+          </p:nvPr>
+        </p:nvPicPr>
+        <p:blipFill>
+          <a:blip r:embed="rId2"/>
+          <a:srcRect b="86554"/>
+          <a:stretch>
+            <a:fillRect/>
+          </a:stretch>
+        </p:blipFill>
+        <p:spPr>
+          <a:xfrm>
+            <a:off x="101757" y="1020348"/>
+            <a:ext cx="5884103" cy="779233"/>
+          </a:xfrm>
+        </p:spPr>
+      </p:pic>
+      <mc:AlternateContent xmlns:mc="http://schemas.openxmlformats.org/markup-compatibility/2006">
+        <mc:Choice xmlns:a14="http://schemas.microsoft.com/office/drawing/2010/main" Requires="a14">
+          <p:sp>
+            <p:nvSpPr>
+              <p:cNvPr id="19" name="Content Placeholder 2">
+                <a:extLst>
+                  <a:ext uri="{FF2B5EF4-FFF2-40B4-BE49-F238E27FC236}">
+                    <a16:creationId xmlns:a16="http://schemas.microsoft.com/office/drawing/2014/main" id="{AEA4C29C-5378-A904-8255-F38110446D00}"/>
+                  </a:ext>
+                </a:extLst>
+              </p:cNvPr>
+              <p:cNvSpPr txBox="1">
+                <a:spLocks/>
+              </p:cNvSpPr>
+              <p:nvPr/>
+            </p:nvSpPr>
+            <p:spPr>
+              <a:xfrm>
+                <a:off x="565247" y="3166281"/>
+                <a:ext cx="5423634" cy="3077569"/>
+              </a:xfrm>
+              <a:prstGeom prst="rect">
+                <a:avLst/>
+              </a:prstGeom>
+            </p:spPr>
+            <p:txBody>
+              <a:bodyPr vert="horz" lIns="91440" tIns="45720" rIns="91440" bIns="45720" rtlCol="0">
+                <a:normAutofit fontScale="55000" lnSpcReduction="20000"/>
+              </a:bodyPr>
+              <a:lstStyle>
+                <a:lvl1pPr marL="228600" indent="-228600" algn="l" defTabSz="914400" rtl="0" eaLnBrk="1" latinLnBrk="0" hangingPunct="1">
+                  <a:lnSpc>
+                    <a:spcPct val="90000"/>
+                  </a:lnSpc>
+                  <a:spcBef>
+                    <a:spcPts val="1000"/>
+                  </a:spcBef>
+                  <a:buFont typeface="Arial" panose="020B0604020202020204" pitchFamily="34" charset="0"/>
+                  <a:buChar char="•"/>
+                  <a:defRPr sz="2800" kern="1200">
+                    <a:solidFill>
+                      <a:schemeClr val="accent6">
+                        <a:lumMod val="75000"/>
+                      </a:schemeClr>
+                    </a:solidFill>
+                    <a:latin typeface="Trebuchet MS" panose="020B0603020202020204" pitchFamily="34" charset="0"/>
+                    <a:ea typeface="+mn-ea"/>
+                    <a:cs typeface="+mn-cs"/>
+                  </a:defRPr>
+                </a:lvl1pPr>
+                <a:lvl2pPr marL="685800" indent="-228600" algn="l" defTabSz="914400" rtl="0" eaLnBrk="1" latinLnBrk="0" hangingPunct="1">
+                  <a:lnSpc>
+                    <a:spcPct val="90000"/>
+                  </a:lnSpc>
+                  <a:spcBef>
+                    <a:spcPts val="500"/>
+                  </a:spcBef>
+                  <a:buFont typeface="Arial" panose="020B0604020202020204" pitchFamily="34" charset="0"/>
+                  <a:buChar char="•"/>
+                  <a:defRPr sz="2400" kern="1200">
+                    <a:solidFill>
+                      <a:schemeClr val="accent6">
+                        <a:lumMod val="75000"/>
+                      </a:schemeClr>
+                    </a:solidFill>
+                    <a:latin typeface="Trebuchet MS" panose="020B0603020202020204" pitchFamily="34" charset="0"/>
+                    <a:ea typeface="+mn-ea"/>
+                    <a:cs typeface="+mn-cs"/>
+                  </a:defRPr>
+                </a:lvl2pPr>
+                <a:lvl3pPr marL="1143000" indent="-228600" algn="l" defTabSz="914400" rtl="0" eaLnBrk="1" latinLnBrk="0" hangingPunct="1">
+                  <a:lnSpc>
+                    <a:spcPct val="90000"/>
+                  </a:lnSpc>
+                  <a:spcBef>
+                    <a:spcPts val="500"/>
+                  </a:spcBef>
+                  <a:buFont typeface="Arial" panose="020B0604020202020204" pitchFamily="34" charset="0"/>
+                  <a:buChar char="•"/>
+                  <a:defRPr sz="2000" kern="1200">
+                    <a:solidFill>
+                      <a:schemeClr val="accent6">
+                        <a:lumMod val="75000"/>
+                      </a:schemeClr>
+                    </a:solidFill>
+                    <a:latin typeface="Trebuchet MS" panose="020B0603020202020204" pitchFamily="34" charset="0"/>
+                    <a:ea typeface="+mn-ea"/>
+                    <a:cs typeface="+mn-cs"/>
+                  </a:defRPr>
+                </a:lvl3pPr>
+                <a:lvl4pPr marL="1600200" indent="-228600" algn="l" defTabSz="914400" rtl="0" eaLnBrk="1" latinLnBrk="0" hangingPunct="1">
+                  <a:lnSpc>
+                    <a:spcPct val="90000"/>
+                  </a:lnSpc>
+                  <a:spcBef>
+                    <a:spcPts val="500"/>
+                  </a:spcBef>
+                  <a:buFont typeface="Arial" panose="020B0604020202020204" pitchFamily="34" charset="0"/>
+                  <a:buChar char="•"/>
+                  <a:defRPr sz="1800" kern="1200">
+                    <a:solidFill>
+                      <a:schemeClr val="accent6">
+                        <a:lumMod val="75000"/>
+                      </a:schemeClr>
+                    </a:solidFill>
+                    <a:latin typeface="Trebuchet MS" panose="020B0603020202020204" pitchFamily="34" charset="0"/>
+                    <a:ea typeface="+mn-ea"/>
+                    <a:cs typeface="+mn-cs"/>
+                  </a:defRPr>
+                </a:lvl4pPr>
+                <a:lvl5pPr marL="2057400" indent="-228600" algn="l" defTabSz="914400" rtl="0" eaLnBrk="1" latinLnBrk="0" hangingPunct="1">
+                  <a:lnSpc>
+                    <a:spcPct val="90000"/>
+                  </a:lnSpc>
+                  <a:spcBef>
+                    <a:spcPts val="500"/>
+                  </a:spcBef>
+                  <a:buFont typeface="Arial" panose="020B0604020202020204" pitchFamily="34" charset="0"/>
+                  <a:buChar char="•"/>
+                  <a:defRPr sz="1800" kern="1200">
+                    <a:solidFill>
+                      <a:schemeClr val="accent6">
+                        <a:lumMod val="75000"/>
+                      </a:schemeClr>
+                    </a:solidFill>
+                    <a:latin typeface="Trebuchet MS" panose="020B0603020202020204" pitchFamily="34" charset="0"/>
+                    <a:ea typeface="+mn-ea"/>
+                    <a:cs typeface="+mn-cs"/>
+                  </a:defRPr>
+                </a:lvl5pPr>
+                <a:lvl6pPr marL="2514600" indent="-228600" algn="l" defTabSz="914400" rtl="0" eaLnBrk="1" latinLnBrk="0" hangingPunct="1">
+                  <a:lnSpc>
+                    <a:spcPct val="90000"/>
+                  </a:lnSpc>
+                  <a:spcBef>
+                    <a:spcPts val="500"/>
+                  </a:spcBef>
+                  <a:buFont typeface="Arial" panose="020B0604020202020204" pitchFamily="34" charset="0"/>
+                  <a:buChar char="•"/>
+                  <a:defRPr sz="1800" kern="1200">
+                    <a:solidFill>
+                      <a:schemeClr val="tx1"/>
+                    </a:solidFill>
+                    <a:latin typeface="+mn-lt"/>
+                    <a:ea typeface="+mn-ea"/>
+                    <a:cs typeface="+mn-cs"/>
+                  </a:defRPr>
+                </a:lvl6pPr>
+                <a:lvl7pPr marL="2971800" indent="-228600" algn="l" defTabSz="914400" rtl="0" eaLnBrk="1" latinLnBrk="0" hangingPunct="1">
+                  <a:lnSpc>
+                    <a:spcPct val="90000"/>
+                  </a:lnSpc>
+                  <a:spcBef>
+                    <a:spcPts val="500"/>
+                  </a:spcBef>
+                  <a:buFont typeface="Arial" panose="020B0604020202020204" pitchFamily="34" charset="0"/>
+                  <a:buChar char="•"/>
+                  <a:defRPr sz="1800" kern="1200">
+                    <a:solidFill>
+                      <a:schemeClr val="tx1"/>
+                    </a:solidFill>
+                    <a:latin typeface="+mn-lt"/>
+                    <a:ea typeface="+mn-ea"/>
+                    <a:cs typeface="+mn-cs"/>
+                  </a:defRPr>
+                </a:lvl7pPr>
+                <a:lvl8pPr marL="3429000" indent="-228600" algn="l" defTabSz="914400" rtl="0" eaLnBrk="1" latinLnBrk="0" hangingPunct="1">
+                  <a:lnSpc>
+                    <a:spcPct val="90000"/>
+                  </a:lnSpc>
+                  <a:spcBef>
+                    <a:spcPts val="500"/>
+                  </a:spcBef>
+                  <a:buFont typeface="Arial" panose="020B0604020202020204" pitchFamily="34" charset="0"/>
+                  <a:buChar char="•"/>
+                  <a:defRPr sz="1800" kern="1200">
+                    <a:solidFill>
+                      <a:schemeClr val="tx1"/>
+                    </a:solidFill>
+                    <a:latin typeface="+mn-lt"/>
+                    <a:ea typeface="+mn-ea"/>
+                    <a:cs typeface="+mn-cs"/>
+                  </a:defRPr>
+                </a:lvl8pPr>
+                <a:lvl9pPr marL="3886200" indent="-228600" algn="l" defTabSz="914400" rtl="0" eaLnBrk="1" latinLnBrk="0" hangingPunct="1">
+                  <a:lnSpc>
+                    <a:spcPct val="90000"/>
+                  </a:lnSpc>
+                  <a:spcBef>
+                    <a:spcPts val="500"/>
+                  </a:spcBef>
+                  <a:buFont typeface="Arial" panose="020B0604020202020204" pitchFamily="34" charset="0"/>
+                  <a:buChar char="•"/>
+                  <a:defRPr sz="1800" kern="1200">
+                    <a:solidFill>
+                      <a:schemeClr val="tx1"/>
+                    </a:solidFill>
+                    <a:latin typeface="+mn-lt"/>
+                    <a:ea typeface="+mn-ea"/>
+                    <a:cs typeface="+mn-cs"/>
+                  </a:defRPr>
+                </a:lvl9pPr>
+              </a:lstStyle>
+              <a:p>
+                <a:r>
+                  <a:rPr lang="en-US" sz="2000" dirty="0"/>
+                  <a:t>Model used is a 4 layer Fourier Neural Operator (FNO)</a:t>
+                </a:r>
+              </a:p>
+              <a:p>
+                <a:r>
+                  <a:rPr lang="en-US" sz="2000" i="1" dirty="0"/>
+                  <a:t>‘a’</a:t>
+                </a:r>
+                <a:r>
+                  <a:rPr lang="en-US" sz="2000" dirty="0"/>
+                  <a:t> is our 3x32x32 input of geometry, wavevector, and band.</a:t>
+                </a:r>
+              </a:p>
+              <a:p>
+                <a:pPr lvl="1"/>
+                <a:r>
+                  <a:rPr lang="en-US" sz="1600" dirty="0"/>
+                  <a:t>Wavevector uses a 2D wavelet embedding representation</a:t>
+                </a:r>
+              </a:p>
+              <a:p>
+                <a:pPr lvl="1"/>
+                <a:r>
+                  <a:rPr lang="en-US" sz="1600" dirty="0"/>
+                  <a:t>Band uses a scalar wavelet embedding representation</a:t>
+                </a:r>
+              </a:p>
+              <a:p>
+                <a:r>
+                  <a:rPr lang="en-US" sz="2000" dirty="0"/>
+                  <a:t>First layer </a:t>
+                </a:r>
+                <a:r>
+                  <a:rPr lang="en-US" sz="2000" i="1" dirty="0"/>
+                  <a:t>‘P’</a:t>
+                </a:r>
+                <a:r>
+                  <a:rPr lang="en-US" sz="2000" dirty="0"/>
+                  <a:t> lifts </a:t>
+                </a:r>
+                <a:r>
+                  <a:rPr lang="en-US" sz="2000" i="1" dirty="0"/>
+                  <a:t>‘a’</a:t>
+                </a:r>
+                <a:r>
+                  <a:rPr lang="en-US" sz="2000" dirty="0"/>
+                  <a:t> into a higher dimensional space.</a:t>
+                </a:r>
+              </a:p>
+              <a:p>
+                <a:pPr lvl="1"/>
+                <a:r>
+                  <a:rPr lang="en-US" sz="1600" dirty="0"/>
+                  <a:t>Yields multiple channels to for model to learn different features on.</a:t>
+                </a:r>
+              </a:p>
+              <a:p>
+                <a:r>
+                  <a:rPr lang="en-US" sz="2000" dirty="0"/>
+                  <a:t>FNO layer (x4)</a:t>
+                </a:r>
+              </a:p>
+              <a:p>
+                <a:pPr lvl="1"/>
+                <a:r>
+                  <a:rPr lang="en-US" sz="1600" dirty="0"/>
+                  <a:t>Input data passes through a spectral branch (top) and spatial branch (bottom)</a:t>
+                </a:r>
+              </a:p>
+              <a:p>
+                <a:pPr lvl="1"/>
+                <a:r>
+                  <a:rPr lang="en-US" sz="1600" dirty="0"/>
+                  <a:t>Spectral branch undergoes a Fourier transform, a learned matrix </a:t>
+                </a:r>
+                <a:r>
+                  <a:rPr lang="en-US" sz="2000" i="1" dirty="0"/>
+                  <a:t>‘R’</a:t>
+                </a:r>
+                <a:r>
+                  <a:rPr lang="en-US" sz="1600" dirty="0"/>
+                  <a:t> multiplication, and an inverse Fourier transform, and addition of learned biases </a:t>
+                </a:r>
+                <a:r>
+                  <a:rPr lang="en-US" sz="2000" i="1" dirty="0"/>
+                  <a:t>‘b’</a:t>
+                </a:r>
+                <a:endParaRPr lang="en-US" sz="1600" dirty="0"/>
+              </a:p>
+              <a:p>
+                <a:pPr lvl="1"/>
+                <a:r>
+                  <a:rPr lang="en-US" sz="1600" dirty="0"/>
+                  <a:t>Spatial branch undergoes learned matrix </a:t>
+                </a:r>
+                <a:r>
+                  <a:rPr lang="en-US" sz="1600" i="1" dirty="0"/>
+                  <a:t>‘W’</a:t>
+                </a:r>
+                <a:r>
+                  <a:rPr lang="en-US" sz="1600" dirty="0"/>
+                  <a:t> multiplication</a:t>
+                </a:r>
+              </a:p>
+              <a:p>
+                <a:pPr lvl="1"/>
+                <a:r>
+                  <a:rPr lang="en-US" sz="1600" dirty="0"/>
+                  <a:t>Branch outputs summed and passed through non-linear function </a:t>
+                </a:r>
+                <a:r>
+                  <a:rPr lang="en-US" sz="1600" i="1" dirty="0"/>
+                  <a:t>‘</a:t>
+                </a:r>
+                <a:r>
+                  <a:rPr lang="el-GR" sz="1600" i="1" dirty="0"/>
+                  <a:t>σ</a:t>
+                </a:r>
+                <a:r>
+                  <a:rPr lang="en-US" sz="1600" i="1" dirty="0"/>
+                  <a:t>’</a:t>
+                </a:r>
+              </a:p>
+              <a:p>
+                <a:r>
+                  <a:rPr lang="en-US" sz="2000" dirty="0"/>
+                  <a:t>Last layer returns output ‘u’ with shape 5x32x32</a:t>
+                </a:r>
+              </a:p>
+              <a:p>
+                <a:pPr lvl="1"/>
+                <a:r>
+                  <a:rPr lang="en-US" sz="1600" dirty="0"/>
+                  <a:t>First channel is a prediction of eigenfrequency ‘</a:t>
+                </a:r>
+                <a14:m>
+                  <m:oMath xmlns:m="http://schemas.openxmlformats.org/officeDocument/2006/math">
+                    <m:r>
+                      <m:rPr>
+                        <m:sty m:val="p"/>
+                      </m:rPr>
+                      <a:rPr lang="el-GR" sz="1600" i="1" smtClean="0">
+                        <a:latin typeface="Cambria Math" panose="02040503050406030204" pitchFamily="18" charset="0"/>
+                      </a:rPr>
+                      <m:t>ω</m:t>
+                    </m:r>
+                  </m:oMath>
+                </a14:m>
+                <a:r>
+                  <a:rPr lang="en-US" sz="1600" dirty="0"/>
+                  <a:t>’</a:t>
+                </a:r>
+              </a:p>
+              <a:p>
+                <a:pPr lvl="1"/>
+                <a:r>
+                  <a:rPr lang="en-US" sz="1600" dirty="0"/>
+                  <a:t>Next four channels are real and imaginary displacements in ‘x’ and ‘y’</a:t>
+                </a:r>
+              </a:p>
+            </p:txBody>
+          </p:sp>
+        </mc:Choice>
+        <mc:Fallback>
+          <p:sp>
+            <p:nvSpPr>
+              <p:cNvPr id="19" name="Content Placeholder 2">
+                <a:extLst>
+                  <a:ext uri="{FF2B5EF4-FFF2-40B4-BE49-F238E27FC236}">
+                    <a16:creationId xmlns:a16="http://schemas.microsoft.com/office/drawing/2014/main" id="{AEA4C29C-5378-A904-8255-F38110446D00}"/>
+                  </a:ext>
+                </a:extLst>
+              </p:cNvPr>
+              <p:cNvSpPr txBox="1">
+                <a:spLocks noRot="1" noChangeAspect="1" noMove="1" noResize="1" noEditPoints="1" noAdjustHandles="1" noChangeArrowheads="1" noChangeShapeType="1" noTextEdit="1"/>
+              </p:cNvSpPr>
+              <p:nvPr/>
+            </p:nvSpPr>
+            <p:spPr>
+              <a:xfrm>
+                <a:off x="565247" y="3166281"/>
+                <a:ext cx="5423634" cy="3077569"/>
+              </a:xfrm>
+              <a:prstGeom prst="rect">
+                <a:avLst/>
+              </a:prstGeom>
+              <a:blipFill>
+                <a:blip r:embed="rId3"/>
+                <a:stretch>
+                  <a:fillRect t="-1782"/>
+                </a:stretch>
+              </a:blipFill>
+            </p:spPr>
+            <p:txBody>
+              <a:bodyPr/>
+              <a:lstStyle/>
+              <a:p>
+                <a:r>
+                  <a:rPr lang="en-US">
+                    <a:noFill/>
+                  </a:rPr>
+                  <a:t> </a:t>
+                </a:r>
+              </a:p>
+            </p:txBody>
+          </p:sp>
+        </mc:Fallback>
+      </mc:AlternateContent>
+      <p:pic>
+        <p:nvPicPr>
+          <p:cNvPr id="3" name="Content Placeholder 17" descr="A diagram of a machine&#10;&#10;Description automatically generated">
+            <a:extLst>
+              <a:ext uri="{FF2B5EF4-FFF2-40B4-BE49-F238E27FC236}">
+                <a16:creationId xmlns:a16="http://schemas.microsoft.com/office/drawing/2014/main" id="{9F80B38F-9801-2B24-02C0-F725A3554287}"/>
+              </a:ext>
+            </a:extLst>
+          </p:cNvPr>
+          <p:cNvPicPr>
+            <a:picLocks noChangeAspect="1"/>
+          </p:cNvPicPr>
+          <p:nvPr/>
+        </p:nvPicPr>
+        <p:blipFill>
+          <a:blip r:embed="rId2"/>
+          <a:srcRect t="81210" b="1447"/>
+          <a:stretch>
+            <a:fillRect/>
+          </a:stretch>
+        </p:blipFill>
+        <p:spPr>
+          <a:xfrm>
+            <a:off x="101757" y="1799582"/>
+            <a:ext cx="5884103" cy="1005034"/>
+          </a:xfrm>
+          <a:prstGeom prst="rect">
+            <a:avLst/>
+          </a:prstGeom>
+        </p:spPr>
+      </p:pic>
+      <p:pic>
+        <p:nvPicPr>
+          <p:cNvPr id="6" name="Content Placeholder 5">
+            <a:extLst>
+              <a:ext uri="{FF2B5EF4-FFF2-40B4-BE49-F238E27FC236}">
+                <a16:creationId xmlns:a16="http://schemas.microsoft.com/office/drawing/2014/main" id="{A758BA55-AF75-F30A-97A6-018278679AF0}"/>
+              </a:ext>
+            </a:extLst>
+          </p:cNvPr>
+          <p:cNvPicPr>
+            <a:picLocks noChangeAspect="1"/>
+          </p:cNvPicPr>
+          <p:nvPr/>
+        </p:nvPicPr>
+        <p:blipFill>
+          <a:blip r:embed="rId4"/>
+          <a:stretch>
+            <a:fillRect/>
+          </a:stretch>
+        </p:blipFill>
+        <p:spPr>
+          <a:xfrm>
+            <a:off x="6255796" y="1046323"/>
+            <a:ext cx="5658960" cy="1569638"/>
+          </a:xfrm>
+          <a:prstGeom prst="rect">
+            <a:avLst/>
+          </a:prstGeom>
+        </p:spPr>
+      </p:pic>
+      <p:pic>
+        <p:nvPicPr>
+          <p:cNvPr id="7" name="Picture 6">
+            <a:extLst>
+              <a:ext uri="{FF2B5EF4-FFF2-40B4-BE49-F238E27FC236}">
+                <a16:creationId xmlns:a16="http://schemas.microsoft.com/office/drawing/2014/main" id="{CF27F1A0-309E-4526-FFB6-8BEF4468E794}"/>
+              </a:ext>
+            </a:extLst>
+          </p:cNvPr>
+          <p:cNvPicPr>
+            <a:picLocks noChangeAspect="1"/>
+          </p:cNvPicPr>
+          <p:nvPr/>
+        </p:nvPicPr>
+        <p:blipFill>
+          <a:blip r:embed="rId5"/>
+          <a:stretch>
+            <a:fillRect/>
+          </a:stretch>
+        </p:blipFill>
+        <p:spPr>
+          <a:xfrm>
+            <a:off x="6203121" y="2774292"/>
+            <a:ext cx="5708615" cy="3396968"/>
+          </a:xfrm>
+          <a:prstGeom prst="rect">
+            <a:avLst/>
+          </a:prstGeom>
+        </p:spPr>
+      </p:pic>
+      <p:sp>
+        <p:nvSpPr>
+          <p:cNvPr id="8" name="TextBox 7">
+            <a:extLst>
+              <a:ext uri="{FF2B5EF4-FFF2-40B4-BE49-F238E27FC236}">
+                <a16:creationId xmlns:a16="http://schemas.microsoft.com/office/drawing/2014/main" id="{16385AB2-9EE2-FC5E-6290-B32C753B48F6}"/>
+              </a:ext>
+            </a:extLst>
+          </p:cNvPr>
+          <p:cNvSpPr txBox="1"/>
+          <p:nvPr/>
+        </p:nvSpPr>
+        <p:spPr>
+          <a:xfrm>
+            <a:off x="6252778" y="834085"/>
+            <a:ext cx="5658958" cy="276999"/>
+          </a:xfrm>
+          <a:prstGeom prst="rect">
+            <a:avLst/>
+          </a:prstGeom>
+          <a:noFill/>
+        </p:spPr>
+        <p:txBody>
+          <a:bodyPr wrap="square" rtlCol="0">
+            <a:spAutoFit/>
+          </a:bodyPr>
+          <a:lstStyle/>
+          <a:p>
+            <a:r>
+              <a:rPr lang="en-US" sz="1200" dirty="0">
+                <a:solidFill>
+                  <a:schemeClr val="accent6">
+                    <a:lumMod val="75000"/>
+                  </a:schemeClr>
+                </a:solidFill>
+                <a:latin typeface="Trebuchet MS" panose="020B0603020202020204" pitchFamily="34" charset="0"/>
+              </a:rPr>
+              <a:t>Inputs: Geometry, Wavevector, and Band with wavelet embeddings</a:t>
+            </a:r>
+          </a:p>
+        </p:txBody>
+      </p:sp>
+      <p:sp>
+        <p:nvSpPr>
+          <p:cNvPr id="10" name="TextBox 9">
+            <a:extLst>
+              <a:ext uri="{FF2B5EF4-FFF2-40B4-BE49-F238E27FC236}">
+                <a16:creationId xmlns:a16="http://schemas.microsoft.com/office/drawing/2014/main" id="{64BAD03D-3ADE-8095-026F-472A90AAD1E9}"/>
+              </a:ext>
+            </a:extLst>
+          </p:cNvPr>
+          <p:cNvSpPr txBox="1"/>
+          <p:nvPr/>
+        </p:nvSpPr>
+        <p:spPr>
+          <a:xfrm>
+            <a:off x="6252777" y="2527617"/>
+            <a:ext cx="5658959" cy="276999"/>
+          </a:xfrm>
+          <a:prstGeom prst="rect">
+            <a:avLst/>
+          </a:prstGeom>
+          <a:noFill/>
+        </p:spPr>
+        <p:txBody>
+          <a:bodyPr wrap="square" rtlCol="0">
+            <a:spAutoFit/>
+          </a:bodyPr>
+          <a:lstStyle/>
+          <a:p>
+            <a:r>
+              <a:rPr lang="en-US" sz="1200" dirty="0">
+                <a:solidFill>
+                  <a:schemeClr val="accent6">
+                    <a:lumMod val="75000"/>
+                  </a:schemeClr>
+                </a:solidFill>
+                <a:latin typeface="Trebuchet MS" panose="020B0603020202020204" pitchFamily="34" charset="0"/>
+              </a:rPr>
+              <a:t>Outputs, Predictions, &amp; Differences at median (50</a:t>
+            </a:r>
+            <a:r>
+              <a:rPr lang="en-US" sz="1200" baseline="30000" dirty="0">
+                <a:solidFill>
+                  <a:schemeClr val="accent6">
+                    <a:lumMod val="75000"/>
+                  </a:schemeClr>
+                </a:solidFill>
+                <a:latin typeface="Trebuchet MS" panose="020B0603020202020204" pitchFamily="34" charset="0"/>
+              </a:rPr>
+              <a:t>th</a:t>
+            </a:r>
+            <a:r>
+              <a:rPr lang="en-US" sz="1200" dirty="0">
+                <a:solidFill>
+                  <a:schemeClr val="accent6">
+                    <a:lumMod val="75000"/>
+                  </a:schemeClr>
+                </a:solidFill>
+                <a:latin typeface="Trebuchet MS" panose="020B0603020202020204" pitchFamily="34" charset="0"/>
+              </a:rPr>
+              <a:t> percentile) performance</a:t>
+            </a:r>
+          </a:p>
+        </p:txBody>
+      </p:sp>
+    </p:spTree>
+    <p:extLst>
+      <p:ext uri="{BB962C8B-B14F-4D97-AF65-F5344CB8AC3E}">
+        <p14:creationId xmlns:p14="http://schemas.microsoft.com/office/powerpoint/2010/main" val="3089376292"/>
+      </p:ext>
+    </p:extLst>
+  </p:cSld>
+  <p:clrMapOvr>
+    <a:masterClrMapping/>
+  </p:clrMapOvr>
+</p:sld>
+</file>
+
+<file path=ppt/slides/slide3.xml><?xml version="1.0" encoding="utf-8"?>
+<p:sld xmlns:a="http://schemas.openxmlformats.org/drawingml/2006/main" xmlns:r="http://schemas.openxmlformats.org/officeDocument/2006/relationships" xmlns:p="http://schemas.openxmlformats.org/presentationml/2006/main">
+  <p:cSld>
+    <p:spTree>
+      <p:nvGrpSpPr>
+        <p:cNvPr id="1" name="">
+          <a:extLst>
+            <a:ext uri="{FF2B5EF4-FFF2-40B4-BE49-F238E27FC236}">
+              <a16:creationId xmlns:a16="http://schemas.microsoft.com/office/drawing/2014/main" id="{F365A5EE-318E-C2B5-D179-3D7C7F19969B}"/>
+            </a:ext>
+          </a:extLst>
+        </p:cNvPr>
+        <p:cNvGrpSpPr/>
+        <p:nvPr/>
+      </p:nvGrpSpPr>
+      <p:grpSpPr>
+        <a:xfrm>
+          <a:off x="0" y="0"/>
+          <a:ext cx="0" cy="0"/>
+          <a:chOff x="0" y="0"/>
+          <a:chExt cx="0" cy="0"/>
+        </a:xfrm>
+      </p:grpSpPr>
+      <p:sp>
+        <p:nvSpPr>
+          <p:cNvPr id="19" name="Content Placeholder 2">
+            <a:extLst>
+              <a:ext uri="{FF2B5EF4-FFF2-40B4-BE49-F238E27FC236}">
+                <a16:creationId xmlns:a16="http://schemas.microsoft.com/office/drawing/2014/main" id="{82E0060E-354F-58DC-2C56-9C57FA29506A}"/>
               </a:ext>
             </a:extLst>
           </p:cNvPr>
@@ -4446,8 +5258,8 @@
         </p:nvSpPr>
         <p:spPr>
           <a:xfrm>
-            <a:off x="5260076" y="1147083"/>
-            <a:ext cx="6093724" cy="5029883"/>
+            <a:off x="838198" y="1161293"/>
+            <a:ext cx="5479298" cy="5048437"/>
           </a:xfrm>
           <a:prstGeom prst="rect">
             <a:avLst/>
@@ -4633,91 +5445,97 @@
           </a:lstStyle>
           <a:p>
             <a:r>
-              <a:rPr lang="en-US" sz="2000" dirty="0"/>
-              <a:t>The solving of PDEs is the fundamental problem</a:t>
+              <a:rPr lang="en-US" sz="1600" dirty="0"/>
+              <a:t>Model size: </a:t>
+            </a:r>
+            <a:r>
+              <a:rPr lang="en-US" sz="1600" b="1" dirty="0"/>
+              <a:t>272 MB</a:t>
+            </a:r>
+          </a:p>
+          <a:p>
+            <a:r>
+              <a:rPr lang="en-US" sz="1600" dirty="0"/>
+              <a:t>Dataset: </a:t>
             </a:r>
           </a:p>
           <a:p>
             <a:pPr lvl="1"/>
             <a:r>
+              <a:rPr lang="en-US" sz="1200" b="1" dirty="0"/>
+              <a:t>24000 training &amp; 1000 test geometries</a:t>
+            </a:r>
+          </a:p>
+          <a:p>
+            <a:pPr lvl="1"/>
+            <a:r>
+              <a:rPr lang="en-US" sz="1200" b="1" dirty="0"/>
+              <a:t>Each geometry has 95 x and y wavevector combinations</a:t>
+            </a:r>
+          </a:p>
+          <a:p>
+            <a:pPr lvl="1"/>
+            <a:r>
+              <a:rPr lang="en-US" sz="1200" b="1" dirty="0"/>
+              <a:t>Each geometry has 6 displacement modes (bands)</a:t>
+            </a:r>
+          </a:p>
+          <a:p>
+            <a:r>
               <a:rPr lang="en-US" sz="1600" dirty="0"/>
-              <a:t>Analytical solutions are rare for real world problems</a:t>
-            </a:r>
-          </a:p>
-          <a:p>
-            <a:r>
-              <a:rPr lang="en-US" sz="2000" dirty="0"/>
-              <a:t>Numerical approaches (finite element methods)</a:t>
-            </a:r>
-          </a:p>
-          <a:p>
-            <a:pPr lvl="1"/>
+              <a:t>Training criterion: Huber loss (L2, followed by L1)</a:t>
+            </a:r>
+          </a:p>
+          <a:p>
             <a:r>
               <a:rPr lang="en-US" sz="1600" dirty="0"/>
-              <a:t>Slow due to poor scaling laws.</a:t>
-            </a:r>
-          </a:p>
-          <a:p>
-            <a:pPr lvl="1"/>
+              <a:t>Training time: </a:t>
+            </a:r>
+            <a:r>
+              <a:rPr lang="en-US" sz="1600" b="1" dirty="0"/>
+              <a:t>1 day on 1 NVIDIA 4080 GPU</a:t>
+            </a:r>
+          </a:p>
+          <a:p>
             <a:r>
               <a:rPr lang="en-US" sz="1600" dirty="0"/>
-              <a:t>Compute intensive so economically impractical</a:t>
-            </a:r>
-          </a:p>
-          <a:p>
-            <a:r>
-              <a:rPr lang="en-US" sz="2000" dirty="0"/>
-              <a:t>Traditional neural networks</a:t>
-            </a:r>
-          </a:p>
-          <a:p>
-            <a:pPr lvl="1"/>
+              <a:t>Inference time: </a:t>
+            </a:r>
+            <a:r>
+              <a:rPr lang="en-US" sz="1600" b="1" dirty="0"/>
+              <a:t>&lt;1ms per sample</a:t>
+            </a:r>
+          </a:p>
+          <a:p>
             <a:r>
               <a:rPr lang="en-US" sz="1600" dirty="0"/>
-              <a:t>Poor generalizability</a:t>
-            </a:r>
-          </a:p>
-          <a:p>
-            <a:pPr lvl="1"/>
+              <a:t>Performance: </a:t>
+            </a:r>
+            <a:r>
+              <a:rPr lang="en-US" sz="1600" b="1" dirty="0"/>
+              <a:t>Average normalized mean absolute error (NMAE) is 0.35%, median is 0.16% error </a:t>
+            </a:r>
+          </a:p>
+          <a:p>
             <a:r>
               <a:rPr lang="en-US" sz="1600" dirty="0"/>
-              <a:t>Data intensive (upfront costs)</a:t>
-            </a:r>
-          </a:p>
-          <a:p>
-            <a:r>
-              <a:rPr lang="en-US" sz="2000" dirty="0"/>
-              <a:t>Neural operators</a:t>
-            </a:r>
-          </a:p>
-          <a:p>
-            <a:pPr lvl="1"/>
+              <a:t>This model can be used to predict the shapes and temporal frequencies of multiple (6) deformation modes for each geometry, for any wavevector stimuli (within the IBZ)</a:t>
+            </a:r>
+          </a:p>
+          <a:p>
             <a:r>
               <a:rPr lang="en-US" sz="1600" dirty="0"/>
-              <a:t>Generalizable across resolution</a:t>
-            </a:r>
-          </a:p>
-          <a:p>
-            <a:pPr lvl="1"/>
-            <a:r>
-              <a:rPr lang="en-US" sz="1600" dirty="0"/>
-              <a:t>Relatively lightweight, because fundamentally, functions are more efficient representations than pointwise descriptions.</a:t>
-            </a:r>
-          </a:p>
-          <a:p>
-            <a:r>
-              <a:rPr lang="en-US" sz="2000" dirty="0"/>
-              <a:t>The applications are at minimum, anywhere where PDEs are used.</a:t>
+              <a:t>Biggest contribution to performance is from wavelet embeddings for wavevector and band information which more richly interact with model weights in the spectral and spatial branches of each FNO layer.</a:t>
             </a:r>
           </a:p>
         </p:txBody>
       </p:sp>
       <p:pic>
         <p:nvPicPr>
-          <p:cNvPr id="12" name="Picture 11" descr="A multicolored metal object with a wireframe&#10;&#10;Description automatically generated">
-            <a:extLst>
-              <a:ext uri="{FF2B5EF4-FFF2-40B4-BE49-F238E27FC236}">
-                <a16:creationId xmlns:a16="http://schemas.microsoft.com/office/drawing/2014/main" id="{AC05DB1C-6E55-FDB0-6300-A3BE99906540}"/>
+          <p:cNvPr id="4" name="Picture 3">
+            <a:extLst>
+              <a:ext uri="{FF2B5EF4-FFF2-40B4-BE49-F238E27FC236}">
+                <a16:creationId xmlns:a16="http://schemas.microsoft.com/office/drawing/2014/main" id="{2FF50B20-ABDA-D3D1-DDF5-E589333EB217}"/>
               </a:ext>
             </a:extLst>
           </p:cNvPr>
@@ -4734,90 +5552,20 @@
         </p:blipFill>
         <p:spPr>
           <a:xfrm>
-            <a:off x="838200" y="904751"/>
-            <a:ext cx="3452884" cy="2701882"/>
+            <a:off x="6438615" y="0"/>
+            <a:ext cx="5241201" cy="3200702"/>
           </a:xfrm>
           <a:prstGeom prst="rect">
             <a:avLst/>
           </a:prstGeom>
         </p:spPr>
       </p:pic>
-      <p:sp>
-        <p:nvSpPr>
-          <p:cNvPr id="14" name="TextBox 13">
-            <a:extLst>
-              <a:ext uri="{FF2B5EF4-FFF2-40B4-BE49-F238E27FC236}">
-                <a16:creationId xmlns:a16="http://schemas.microsoft.com/office/drawing/2014/main" id="{ACE3D4DA-1313-2B09-FA65-E15A7444202A}"/>
-              </a:ext>
-            </a:extLst>
-          </p:cNvPr>
-          <p:cNvSpPr txBox="1"/>
-          <p:nvPr/>
-        </p:nvSpPr>
-        <p:spPr>
-          <a:xfrm>
-            <a:off x="838200" y="3606633"/>
-            <a:ext cx="3043451" cy="461665"/>
-          </a:xfrm>
-          <a:prstGeom prst="rect">
-            <a:avLst/>
-          </a:prstGeom>
-          <a:noFill/>
-        </p:spPr>
-        <p:txBody>
-          <a:bodyPr wrap="square">
-            <a:spAutoFit/>
-          </a:bodyPr>
-          <a:lstStyle/>
-          <a:p>
-            <a:r>
-              <a:rPr lang="en-US" sz="1200" dirty="0"/>
-              <a:t>https://www.cambridge-dt.com/finite-element-analysis-predicting-the-real-world/</a:t>
-            </a:r>
-          </a:p>
-        </p:txBody>
-      </p:sp>
-      <p:sp>
-        <p:nvSpPr>
-          <p:cNvPr id="16" name="TextBox 15">
-            <a:extLst>
-              <a:ext uri="{FF2B5EF4-FFF2-40B4-BE49-F238E27FC236}">
-                <a16:creationId xmlns:a16="http://schemas.microsoft.com/office/drawing/2014/main" id="{15C7D23A-1B76-BCA2-A6F9-70228E62952F}"/>
-              </a:ext>
-            </a:extLst>
-          </p:cNvPr>
-          <p:cNvSpPr txBox="1"/>
-          <p:nvPr/>
-        </p:nvSpPr>
-        <p:spPr>
-          <a:xfrm>
-            <a:off x="1653268" y="6591300"/>
-            <a:ext cx="6093724" cy="276999"/>
-          </a:xfrm>
-          <a:prstGeom prst="rect">
-            <a:avLst/>
-          </a:prstGeom>
-          <a:noFill/>
-        </p:spPr>
-        <p:txBody>
-          <a:bodyPr wrap="square">
-            <a:spAutoFit/>
-          </a:bodyPr>
-          <a:lstStyle/>
-          <a:p>
-            <a:r>
-              <a:rPr lang="en-US" sz="1200" dirty="0"/>
-              <a:t>https://www.ibm.com/topics/neural-networks</a:t>
-            </a:r>
-          </a:p>
-        </p:txBody>
-      </p:sp>
       <p:pic>
         <p:nvPicPr>
-          <p:cNvPr id="18" name="Picture 17" descr="A diagram of a network&#10;&#10;Description automatically generated">
-            <a:extLst>
-              <a:ext uri="{FF2B5EF4-FFF2-40B4-BE49-F238E27FC236}">
-                <a16:creationId xmlns:a16="http://schemas.microsoft.com/office/drawing/2014/main" id="{80B82749-65B7-EC6C-252B-C6D714E6EBFC}"/>
+          <p:cNvPr id="32" name="Picture 31">
+            <a:extLst>
+              <a:ext uri="{FF2B5EF4-FFF2-40B4-BE49-F238E27FC236}">
+                <a16:creationId xmlns:a16="http://schemas.microsoft.com/office/drawing/2014/main" id="{BF26D304-0F58-6907-6796-0308AD89FEC3}"/>
               </a:ext>
             </a:extLst>
           </p:cNvPr>
@@ -4828,6 +5576,730 @@
         </p:nvPicPr>
         <p:blipFill>
           <a:blip r:embed="rId3"/>
+          <a:stretch>
+            <a:fillRect/>
+          </a:stretch>
+        </p:blipFill>
+        <p:spPr>
+          <a:xfrm>
+            <a:off x="6438615" y="3429000"/>
+            <a:ext cx="4286250" cy="3429000"/>
+          </a:xfrm>
+          <a:prstGeom prst="rect">
+            <a:avLst/>
+          </a:prstGeom>
+        </p:spPr>
+      </p:pic>
+      <p:sp>
+        <p:nvSpPr>
+          <p:cNvPr id="9" name="TextBox 8">
+            <a:extLst>
+              <a:ext uri="{FF2B5EF4-FFF2-40B4-BE49-F238E27FC236}">
+                <a16:creationId xmlns:a16="http://schemas.microsoft.com/office/drawing/2014/main" id="{8C0E0992-9B15-AF94-EFF2-BD062FD1E7B5}"/>
+              </a:ext>
+            </a:extLst>
+          </p:cNvPr>
+          <p:cNvSpPr txBox="1"/>
+          <p:nvPr/>
+        </p:nvSpPr>
+        <p:spPr>
+          <a:xfrm>
+            <a:off x="10724865" y="4540661"/>
+            <a:ext cx="1076070" cy="461665"/>
+          </a:xfrm>
+          <a:prstGeom prst="rect">
+            <a:avLst/>
+          </a:prstGeom>
+          <a:noFill/>
+        </p:spPr>
+        <p:txBody>
+          <a:bodyPr wrap="square" rtlCol="0">
+            <a:spAutoFit/>
+          </a:bodyPr>
+          <a:lstStyle/>
+          <a:p>
+            <a:r>
+              <a:rPr lang="en-US" sz="1200" dirty="0">
+                <a:solidFill>
+                  <a:schemeClr val="accent6">
+                    <a:lumMod val="75000"/>
+                  </a:schemeClr>
+                </a:solidFill>
+                <a:latin typeface="Trebuchet MS" panose="020B0603020202020204" pitchFamily="34" charset="0"/>
+              </a:rPr>
+              <a:t>Test set</a:t>
+            </a:r>
+          </a:p>
+          <a:p>
+            <a:r>
+              <a:rPr lang="en-US" sz="1200" dirty="0">
+                <a:solidFill>
+                  <a:schemeClr val="accent6">
+                    <a:lumMod val="75000"/>
+                  </a:schemeClr>
+                </a:solidFill>
+                <a:latin typeface="Trebuchet MS" panose="020B0603020202020204" pitchFamily="34" charset="0"/>
+              </a:rPr>
+              <a:t>Performance </a:t>
+            </a:r>
+          </a:p>
+        </p:txBody>
+      </p:sp>
+      <p:cxnSp>
+        <p:nvCxnSpPr>
+          <p:cNvPr id="11" name="Straight Arrow Connector 10">
+            <a:extLst>
+              <a:ext uri="{FF2B5EF4-FFF2-40B4-BE49-F238E27FC236}">
+                <a16:creationId xmlns:a16="http://schemas.microsoft.com/office/drawing/2014/main" id="{A710D06F-C7A2-85D3-1FE6-0CA388FF0AB4}"/>
+              </a:ext>
+            </a:extLst>
+          </p:cNvPr>
+          <p:cNvCxnSpPr>
+            <a:stCxn id="9" idx="0"/>
+          </p:cNvCxnSpPr>
+          <p:nvPr/>
+        </p:nvCxnSpPr>
+        <p:spPr>
+          <a:xfrm flipH="1" flipV="1">
+            <a:off x="10604310" y="4285397"/>
+            <a:ext cx="658590" cy="255264"/>
+          </a:xfrm>
+          <a:prstGeom prst="straightConnector1">
+            <a:avLst/>
+          </a:prstGeom>
+          <a:ln>
+            <a:tailEnd type="triangle"/>
+          </a:ln>
+        </p:spPr>
+        <p:style>
+          <a:lnRef idx="1">
+            <a:schemeClr val="accent1"/>
+          </a:lnRef>
+          <a:fillRef idx="0">
+            <a:schemeClr val="accent1"/>
+          </a:fillRef>
+          <a:effectRef idx="0">
+            <a:schemeClr val="accent1"/>
+          </a:effectRef>
+          <a:fontRef idx="minor">
+            <a:schemeClr val="tx1"/>
+          </a:fontRef>
+        </p:style>
+      </p:cxnSp>
+      <p:sp>
+        <p:nvSpPr>
+          <p:cNvPr id="12" name="TextBox 11">
+            <a:extLst>
+              <a:ext uri="{FF2B5EF4-FFF2-40B4-BE49-F238E27FC236}">
+                <a16:creationId xmlns:a16="http://schemas.microsoft.com/office/drawing/2014/main" id="{9EA1AD01-796C-737A-5B4C-B2506DE0ADC3}"/>
+              </a:ext>
+            </a:extLst>
+          </p:cNvPr>
+          <p:cNvSpPr txBox="1"/>
+          <p:nvPr/>
+        </p:nvSpPr>
+        <p:spPr>
+          <a:xfrm>
+            <a:off x="10724865" y="3200702"/>
+            <a:ext cx="1076070" cy="461665"/>
+          </a:xfrm>
+          <a:prstGeom prst="rect">
+            <a:avLst/>
+          </a:prstGeom>
+          <a:noFill/>
+        </p:spPr>
+        <p:txBody>
+          <a:bodyPr wrap="square" rtlCol="0">
+            <a:spAutoFit/>
+          </a:bodyPr>
+          <a:lstStyle/>
+          <a:p>
+            <a:r>
+              <a:rPr lang="en-US" sz="1200" dirty="0">
+                <a:solidFill>
+                  <a:schemeClr val="accent6">
+                    <a:lumMod val="75000"/>
+                  </a:schemeClr>
+                </a:solidFill>
+                <a:latin typeface="Trebuchet MS" panose="020B0603020202020204" pitchFamily="34" charset="0"/>
+              </a:rPr>
+              <a:t>Dispersion</a:t>
+            </a:r>
+          </a:p>
+          <a:p>
+            <a:r>
+              <a:rPr lang="en-US" sz="1200" dirty="0">
+                <a:solidFill>
+                  <a:schemeClr val="accent6">
+                    <a:lumMod val="75000"/>
+                  </a:schemeClr>
+                </a:solidFill>
+                <a:latin typeface="Trebuchet MS" panose="020B0603020202020204" pitchFamily="34" charset="0"/>
+              </a:rPr>
+              <a:t>Performance </a:t>
+            </a:r>
+          </a:p>
+        </p:txBody>
+      </p:sp>
+      <p:cxnSp>
+        <p:nvCxnSpPr>
+          <p:cNvPr id="14" name="Straight Arrow Connector 13">
+            <a:extLst>
+              <a:ext uri="{FF2B5EF4-FFF2-40B4-BE49-F238E27FC236}">
+                <a16:creationId xmlns:a16="http://schemas.microsoft.com/office/drawing/2014/main" id="{69ADA476-69F4-2A2D-01B0-F53D4802EC39}"/>
+              </a:ext>
+            </a:extLst>
+          </p:cNvPr>
+          <p:cNvCxnSpPr>
+            <a:cxnSpLocks/>
+            <a:stCxn id="12" idx="0"/>
+          </p:cNvCxnSpPr>
+          <p:nvPr/>
+        </p:nvCxnSpPr>
+        <p:spPr>
+          <a:xfrm flipH="1" flipV="1">
+            <a:off x="10603746" y="2934269"/>
+            <a:ext cx="659154" cy="266433"/>
+          </a:xfrm>
+          <a:prstGeom prst="straightConnector1">
+            <a:avLst/>
+          </a:prstGeom>
+          <a:ln>
+            <a:tailEnd type="triangle"/>
+          </a:ln>
+        </p:spPr>
+        <p:style>
+          <a:lnRef idx="1">
+            <a:schemeClr val="accent1"/>
+          </a:lnRef>
+          <a:fillRef idx="0">
+            <a:schemeClr val="accent1"/>
+          </a:fillRef>
+          <a:effectRef idx="0">
+            <a:schemeClr val="accent1"/>
+          </a:effectRef>
+          <a:fontRef idx="minor">
+            <a:schemeClr val="tx1"/>
+          </a:fontRef>
+        </p:style>
+      </p:cxnSp>
+      <p:sp>
+        <p:nvSpPr>
+          <p:cNvPr id="23" name="Title 1">
+            <a:extLst>
+              <a:ext uri="{FF2B5EF4-FFF2-40B4-BE49-F238E27FC236}">
+                <a16:creationId xmlns:a16="http://schemas.microsoft.com/office/drawing/2014/main" id="{889C21EF-1325-9841-15C5-DC99F9ED0A74}"/>
+              </a:ext>
+            </a:extLst>
+          </p:cNvPr>
+          <p:cNvSpPr txBox="1">
+            <a:spLocks/>
+          </p:cNvSpPr>
+          <p:nvPr/>
+        </p:nvSpPr>
+        <p:spPr>
+          <a:xfrm>
+            <a:off x="838200" y="104608"/>
+            <a:ext cx="10515600" cy="783384"/>
+          </a:xfrm>
+          <a:prstGeom prst="rect">
+            <a:avLst/>
+          </a:prstGeom>
+        </p:spPr>
+        <p:txBody>
+          <a:bodyPr vert="horz" lIns="91440" tIns="45720" rIns="91440" bIns="45720" rtlCol="0" anchor="ctr">
+            <a:normAutofit/>
+          </a:bodyPr>
+          <a:lstStyle>
+            <a:lvl1pPr algn="l" defTabSz="914400" rtl="0" eaLnBrk="1" latinLnBrk="0" hangingPunct="1">
+              <a:lnSpc>
+                <a:spcPct val="90000"/>
+              </a:lnSpc>
+              <a:spcBef>
+                <a:spcPct val="0"/>
+              </a:spcBef>
+              <a:buNone/>
+              <a:defRPr sz="4400" b="1" kern="1200">
+                <a:solidFill>
+                  <a:schemeClr val="accent6">
+                    <a:lumMod val="75000"/>
+                  </a:schemeClr>
+                </a:solidFill>
+                <a:latin typeface="Garamond" panose="02020404030301010803" pitchFamily="18" charset="0"/>
+                <a:ea typeface="+mj-ea"/>
+                <a:cs typeface="+mj-cs"/>
+              </a:defRPr>
+            </a:lvl1pPr>
+          </a:lstStyle>
+          <a:p>
+            <a:r>
+              <a:rPr lang="en-US" sz="4000" dirty="0"/>
+              <a:t>Results</a:t>
+            </a:r>
+          </a:p>
+        </p:txBody>
+      </p:sp>
+    </p:spTree>
+    <p:extLst>
+      <p:ext uri="{BB962C8B-B14F-4D97-AF65-F5344CB8AC3E}">
+        <p14:creationId xmlns:p14="http://schemas.microsoft.com/office/powerpoint/2010/main" val="2740797438"/>
+      </p:ext>
+    </p:extLst>
+  </p:cSld>
+  <p:clrMapOvr>
+    <a:masterClrMapping/>
+  </p:clrMapOvr>
+</p:sld>
+</file>
+
+<file path=ppt/slides/slide4.xml><?xml version="1.0" encoding="utf-8"?>
+<p:sld xmlns:a="http://schemas.openxmlformats.org/drawingml/2006/main" xmlns:r="http://schemas.openxmlformats.org/officeDocument/2006/relationships" xmlns:p="http://schemas.openxmlformats.org/presentationml/2006/main" show="0">
+  <p:cSld>
+    <p:spTree>
+      <p:nvGrpSpPr>
+        <p:cNvPr id="1" name=""/>
+        <p:cNvGrpSpPr/>
+        <p:nvPr/>
+      </p:nvGrpSpPr>
+      <p:grpSpPr>
+        <a:xfrm>
+          <a:off x="0" y="0"/>
+          <a:ext cx="0" cy="0"/>
+          <a:chOff x="0" y="0"/>
+          <a:chExt cx="0" cy="0"/>
+        </a:xfrm>
+      </p:grpSpPr>
+      <p:sp>
+        <p:nvSpPr>
+          <p:cNvPr id="2" name="Title 1">
+            <a:extLst>
+              <a:ext uri="{FF2B5EF4-FFF2-40B4-BE49-F238E27FC236}">
+                <a16:creationId xmlns:a16="http://schemas.microsoft.com/office/drawing/2014/main" id="{30C1DE39-28F2-E55C-A968-7BF5DE309FE2}"/>
+              </a:ext>
+            </a:extLst>
+          </p:cNvPr>
+          <p:cNvSpPr>
+            <a:spLocks noGrp="1"/>
+          </p:cNvSpPr>
+          <p:nvPr>
+            <p:ph type="title"/>
+          </p:nvPr>
+        </p:nvSpPr>
+        <p:spPr>
+          <a:xfrm>
+            <a:off x="838200" y="90397"/>
+            <a:ext cx="10515600" cy="1056686"/>
+          </a:xfrm>
+        </p:spPr>
+        <p:txBody>
+          <a:bodyPr/>
+          <a:lstStyle/>
+          <a:p>
+            <a:r>
+              <a:rPr lang="en-US" dirty="0"/>
+              <a:t>Motivation &amp; Applications</a:t>
+            </a:r>
+          </a:p>
+        </p:txBody>
+      </p:sp>
+      <p:sp>
+        <p:nvSpPr>
+          <p:cNvPr id="8" name="Content Placeholder 2">
+            <a:extLst>
+              <a:ext uri="{FF2B5EF4-FFF2-40B4-BE49-F238E27FC236}">
+                <a16:creationId xmlns:a16="http://schemas.microsoft.com/office/drawing/2014/main" id="{76E50227-F1D0-C0CB-9A2A-1A4DB4C8C040}"/>
+              </a:ext>
+            </a:extLst>
+          </p:cNvPr>
+          <p:cNvSpPr txBox="1">
+            <a:spLocks/>
+          </p:cNvSpPr>
+          <p:nvPr/>
+        </p:nvSpPr>
+        <p:spPr>
+          <a:xfrm>
+            <a:off x="5260076" y="1147083"/>
+            <a:ext cx="6093724" cy="5029883"/>
+          </a:xfrm>
+          <a:prstGeom prst="rect">
+            <a:avLst/>
+          </a:prstGeom>
+        </p:spPr>
+        <p:txBody>
+          <a:bodyPr vert="horz" lIns="91440" tIns="45720" rIns="91440" bIns="45720" rtlCol="0">
+            <a:normAutofit/>
+          </a:bodyPr>
+          <a:lstStyle>
+            <a:lvl1pPr marL="228600" indent="-228600" algn="l" defTabSz="914400" rtl="0" eaLnBrk="1" latinLnBrk="0" hangingPunct="1">
+              <a:lnSpc>
+                <a:spcPct val="90000"/>
+              </a:lnSpc>
+              <a:spcBef>
+                <a:spcPts val="1000"/>
+              </a:spcBef>
+              <a:buFont typeface="Arial" panose="020B0604020202020204" pitchFamily="34" charset="0"/>
+              <a:buChar char="•"/>
+              <a:defRPr sz="2800" kern="1200">
+                <a:solidFill>
+                  <a:schemeClr val="accent6">
+                    <a:lumMod val="75000"/>
+                  </a:schemeClr>
+                </a:solidFill>
+                <a:latin typeface="Trebuchet MS" panose="020B0603020202020204" pitchFamily="34" charset="0"/>
+                <a:ea typeface="+mn-ea"/>
+                <a:cs typeface="+mn-cs"/>
+              </a:defRPr>
+            </a:lvl1pPr>
+            <a:lvl2pPr marL="685800" indent="-228600" algn="l" defTabSz="914400" rtl="0" eaLnBrk="1" latinLnBrk="0" hangingPunct="1">
+              <a:lnSpc>
+                <a:spcPct val="90000"/>
+              </a:lnSpc>
+              <a:spcBef>
+                <a:spcPts val="500"/>
+              </a:spcBef>
+              <a:buFont typeface="Arial" panose="020B0604020202020204" pitchFamily="34" charset="0"/>
+              <a:buChar char="•"/>
+              <a:defRPr sz="2400" kern="1200">
+                <a:solidFill>
+                  <a:schemeClr val="accent6">
+                    <a:lumMod val="75000"/>
+                  </a:schemeClr>
+                </a:solidFill>
+                <a:latin typeface="Trebuchet MS" panose="020B0603020202020204" pitchFamily="34" charset="0"/>
+                <a:ea typeface="+mn-ea"/>
+                <a:cs typeface="+mn-cs"/>
+              </a:defRPr>
+            </a:lvl2pPr>
+            <a:lvl3pPr marL="1143000" indent="-228600" algn="l" defTabSz="914400" rtl="0" eaLnBrk="1" latinLnBrk="0" hangingPunct="1">
+              <a:lnSpc>
+                <a:spcPct val="90000"/>
+              </a:lnSpc>
+              <a:spcBef>
+                <a:spcPts val="500"/>
+              </a:spcBef>
+              <a:buFont typeface="Arial" panose="020B0604020202020204" pitchFamily="34" charset="0"/>
+              <a:buChar char="•"/>
+              <a:defRPr sz="2000" kern="1200">
+                <a:solidFill>
+                  <a:schemeClr val="accent6">
+                    <a:lumMod val="75000"/>
+                  </a:schemeClr>
+                </a:solidFill>
+                <a:latin typeface="Trebuchet MS" panose="020B0603020202020204" pitchFamily="34" charset="0"/>
+                <a:ea typeface="+mn-ea"/>
+                <a:cs typeface="+mn-cs"/>
+              </a:defRPr>
+            </a:lvl3pPr>
+            <a:lvl4pPr marL="1600200" indent="-228600" algn="l" defTabSz="914400" rtl="0" eaLnBrk="1" latinLnBrk="0" hangingPunct="1">
+              <a:lnSpc>
+                <a:spcPct val="90000"/>
+              </a:lnSpc>
+              <a:spcBef>
+                <a:spcPts val="500"/>
+              </a:spcBef>
+              <a:buFont typeface="Arial" panose="020B0604020202020204" pitchFamily="34" charset="0"/>
+              <a:buChar char="•"/>
+              <a:defRPr sz="1800" kern="1200">
+                <a:solidFill>
+                  <a:schemeClr val="accent6">
+                    <a:lumMod val="75000"/>
+                  </a:schemeClr>
+                </a:solidFill>
+                <a:latin typeface="Trebuchet MS" panose="020B0603020202020204" pitchFamily="34" charset="0"/>
+                <a:ea typeface="+mn-ea"/>
+                <a:cs typeface="+mn-cs"/>
+              </a:defRPr>
+            </a:lvl4pPr>
+            <a:lvl5pPr marL="2057400" indent="-228600" algn="l" defTabSz="914400" rtl="0" eaLnBrk="1" latinLnBrk="0" hangingPunct="1">
+              <a:lnSpc>
+                <a:spcPct val="90000"/>
+              </a:lnSpc>
+              <a:spcBef>
+                <a:spcPts val="500"/>
+              </a:spcBef>
+              <a:buFont typeface="Arial" panose="020B0604020202020204" pitchFamily="34" charset="0"/>
+              <a:buChar char="•"/>
+              <a:defRPr sz="1800" kern="1200">
+                <a:solidFill>
+                  <a:schemeClr val="accent6">
+                    <a:lumMod val="75000"/>
+                  </a:schemeClr>
+                </a:solidFill>
+                <a:latin typeface="Trebuchet MS" panose="020B0603020202020204" pitchFamily="34" charset="0"/>
+                <a:ea typeface="+mn-ea"/>
+                <a:cs typeface="+mn-cs"/>
+              </a:defRPr>
+            </a:lvl5pPr>
+            <a:lvl6pPr marL="2514600" indent="-228600" algn="l" defTabSz="914400" rtl="0" eaLnBrk="1" latinLnBrk="0" hangingPunct="1">
+              <a:lnSpc>
+                <a:spcPct val="90000"/>
+              </a:lnSpc>
+              <a:spcBef>
+                <a:spcPts val="500"/>
+              </a:spcBef>
+              <a:buFont typeface="Arial" panose="020B0604020202020204" pitchFamily="34" charset="0"/>
+              <a:buChar char="•"/>
+              <a:defRPr sz="1800" kern="1200">
+                <a:solidFill>
+                  <a:schemeClr val="tx1"/>
+                </a:solidFill>
+                <a:latin typeface="+mn-lt"/>
+                <a:ea typeface="+mn-ea"/>
+                <a:cs typeface="+mn-cs"/>
+              </a:defRPr>
+            </a:lvl6pPr>
+            <a:lvl7pPr marL="2971800" indent="-228600" algn="l" defTabSz="914400" rtl="0" eaLnBrk="1" latinLnBrk="0" hangingPunct="1">
+              <a:lnSpc>
+                <a:spcPct val="90000"/>
+              </a:lnSpc>
+              <a:spcBef>
+                <a:spcPts val="500"/>
+              </a:spcBef>
+              <a:buFont typeface="Arial" panose="020B0604020202020204" pitchFamily="34" charset="0"/>
+              <a:buChar char="•"/>
+              <a:defRPr sz="1800" kern="1200">
+                <a:solidFill>
+                  <a:schemeClr val="tx1"/>
+                </a:solidFill>
+                <a:latin typeface="+mn-lt"/>
+                <a:ea typeface="+mn-ea"/>
+                <a:cs typeface="+mn-cs"/>
+              </a:defRPr>
+            </a:lvl7pPr>
+            <a:lvl8pPr marL="3429000" indent="-228600" algn="l" defTabSz="914400" rtl="0" eaLnBrk="1" latinLnBrk="0" hangingPunct="1">
+              <a:lnSpc>
+                <a:spcPct val="90000"/>
+              </a:lnSpc>
+              <a:spcBef>
+                <a:spcPts val="500"/>
+              </a:spcBef>
+              <a:buFont typeface="Arial" panose="020B0604020202020204" pitchFamily="34" charset="0"/>
+              <a:buChar char="•"/>
+              <a:defRPr sz="1800" kern="1200">
+                <a:solidFill>
+                  <a:schemeClr val="tx1"/>
+                </a:solidFill>
+                <a:latin typeface="+mn-lt"/>
+                <a:ea typeface="+mn-ea"/>
+                <a:cs typeface="+mn-cs"/>
+              </a:defRPr>
+            </a:lvl8pPr>
+            <a:lvl9pPr marL="3886200" indent="-228600" algn="l" defTabSz="914400" rtl="0" eaLnBrk="1" latinLnBrk="0" hangingPunct="1">
+              <a:lnSpc>
+                <a:spcPct val="90000"/>
+              </a:lnSpc>
+              <a:spcBef>
+                <a:spcPts val="500"/>
+              </a:spcBef>
+              <a:buFont typeface="Arial" panose="020B0604020202020204" pitchFamily="34" charset="0"/>
+              <a:buChar char="•"/>
+              <a:defRPr sz="1800" kern="1200">
+                <a:solidFill>
+                  <a:schemeClr val="tx1"/>
+                </a:solidFill>
+                <a:latin typeface="+mn-lt"/>
+                <a:ea typeface="+mn-ea"/>
+                <a:cs typeface="+mn-cs"/>
+              </a:defRPr>
+            </a:lvl9pPr>
+          </a:lstStyle>
+          <a:p>
+            <a:r>
+              <a:rPr lang="en-US" sz="2000" dirty="0"/>
+              <a:t>The solving of PDEs is the fundamental problem</a:t>
+            </a:r>
+          </a:p>
+          <a:p>
+            <a:pPr lvl="1"/>
+            <a:r>
+              <a:rPr lang="en-US" sz="1600" dirty="0"/>
+              <a:t>Analytical solutions are rare for real world problems</a:t>
+            </a:r>
+          </a:p>
+          <a:p>
+            <a:r>
+              <a:rPr lang="en-US" sz="2000" dirty="0"/>
+              <a:t>Numerical approaches (finite element methods)</a:t>
+            </a:r>
+          </a:p>
+          <a:p>
+            <a:pPr lvl="1"/>
+            <a:r>
+              <a:rPr lang="en-US" sz="1600" dirty="0"/>
+              <a:t>Slow due to poor scaling laws.</a:t>
+            </a:r>
+          </a:p>
+          <a:p>
+            <a:pPr lvl="1"/>
+            <a:r>
+              <a:rPr lang="en-US" sz="1600" dirty="0"/>
+              <a:t>Compute intensive so economically impractical</a:t>
+            </a:r>
+          </a:p>
+          <a:p>
+            <a:r>
+              <a:rPr lang="en-US" sz="2000" dirty="0"/>
+              <a:t>Traditional neural networks</a:t>
+            </a:r>
+          </a:p>
+          <a:p>
+            <a:pPr lvl="1"/>
+            <a:r>
+              <a:rPr lang="en-US" sz="1600" dirty="0"/>
+              <a:t>Poor generalizability</a:t>
+            </a:r>
+          </a:p>
+          <a:p>
+            <a:pPr lvl="1"/>
+            <a:r>
+              <a:rPr lang="en-US" sz="1600" dirty="0"/>
+              <a:t>Data intensive (upfront costs)</a:t>
+            </a:r>
+          </a:p>
+          <a:p>
+            <a:r>
+              <a:rPr lang="en-US" sz="2000" dirty="0"/>
+              <a:t>Neural operators</a:t>
+            </a:r>
+          </a:p>
+          <a:p>
+            <a:pPr lvl="1"/>
+            <a:r>
+              <a:rPr lang="en-US" sz="1600" dirty="0"/>
+              <a:t>Generalizable across resolution</a:t>
+            </a:r>
+          </a:p>
+          <a:p>
+            <a:pPr lvl="1"/>
+            <a:r>
+              <a:rPr lang="en-US" sz="1600" dirty="0"/>
+              <a:t>Relatively lightweight, because fundamentally, functions are more efficient representations than pointwise descriptions.</a:t>
+            </a:r>
+          </a:p>
+          <a:p>
+            <a:r>
+              <a:rPr lang="en-US" sz="2000" dirty="0"/>
+              <a:t>The applications are at minimum, anywhere where PDEs are used.</a:t>
+            </a:r>
+          </a:p>
+        </p:txBody>
+      </p:sp>
+      <p:pic>
+        <p:nvPicPr>
+          <p:cNvPr id="12" name="Picture 11" descr="A multicolored metal object with a wireframe&#10;&#10;Description automatically generated">
+            <a:extLst>
+              <a:ext uri="{FF2B5EF4-FFF2-40B4-BE49-F238E27FC236}">
+                <a16:creationId xmlns:a16="http://schemas.microsoft.com/office/drawing/2014/main" id="{AC05DB1C-6E55-FDB0-6300-A3BE99906540}"/>
+              </a:ext>
+            </a:extLst>
+          </p:cNvPr>
+          <p:cNvPicPr>
+            <a:picLocks noChangeAspect="1"/>
+          </p:cNvPicPr>
+          <p:nvPr/>
+        </p:nvPicPr>
+        <p:blipFill>
+          <a:blip r:embed="rId3"/>
+          <a:stretch>
+            <a:fillRect/>
+          </a:stretch>
+        </p:blipFill>
+        <p:spPr>
+          <a:xfrm>
+            <a:off x="838200" y="904751"/>
+            <a:ext cx="3452884" cy="2701882"/>
+          </a:xfrm>
+          <a:prstGeom prst="rect">
+            <a:avLst/>
+          </a:prstGeom>
+        </p:spPr>
+      </p:pic>
+      <p:sp>
+        <p:nvSpPr>
+          <p:cNvPr id="14" name="TextBox 13">
+            <a:extLst>
+              <a:ext uri="{FF2B5EF4-FFF2-40B4-BE49-F238E27FC236}">
+                <a16:creationId xmlns:a16="http://schemas.microsoft.com/office/drawing/2014/main" id="{ACE3D4DA-1313-2B09-FA65-E15A7444202A}"/>
+              </a:ext>
+            </a:extLst>
+          </p:cNvPr>
+          <p:cNvSpPr txBox="1"/>
+          <p:nvPr/>
+        </p:nvSpPr>
+        <p:spPr>
+          <a:xfrm>
+            <a:off x="838200" y="3606633"/>
+            <a:ext cx="3043451" cy="461665"/>
+          </a:xfrm>
+          <a:prstGeom prst="rect">
+            <a:avLst/>
+          </a:prstGeom>
+          <a:noFill/>
+        </p:spPr>
+        <p:txBody>
+          <a:bodyPr wrap="square">
+            <a:spAutoFit/>
+          </a:bodyPr>
+          <a:lstStyle/>
+          <a:p>
+            <a:r>
+              <a:rPr lang="en-US" sz="1200" dirty="0"/>
+              <a:t>https://www.cambridge-dt.com/finite-element-analysis-predicting-the-real-world/</a:t>
+            </a:r>
+          </a:p>
+        </p:txBody>
+      </p:sp>
+      <p:sp>
+        <p:nvSpPr>
+          <p:cNvPr id="16" name="TextBox 15">
+            <a:extLst>
+              <a:ext uri="{FF2B5EF4-FFF2-40B4-BE49-F238E27FC236}">
+                <a16:creationId xmlns:a16="http://schemas.microsoft.com/office/drawing/2014/main" id="{15C7D23A-1B76-BCA2-A6F9-70228E62952F}"/>
+              </a:ext>
+            </a:extLst>
+          </p:cNvPr>
+          <p:cNvSpPr txBox="1"/>
+          <p:nvPr/>
+        </p:nvSpPr>
+        <p:spPr>
+          <a:xfrm>
+            <a:off x="1653268" y="6591300"/>
+            <a:ext cx="6093724" cy="276999"/>
+          </a:xfrm>
+          <a:prstGeom prst="rect">
+            <a:avLst/>
+          </a:prstGeom>
+          <a:noFill/>
+        </p:spPr>
+        <p:txBody>
+          <a:bodyPr wrap="square">
+            <a:spAutoFit/>
+          </a:bodyPr>
+          <a:lstStyle/>
+          <a:p>
+            <a:r>
+              <a:rPr lang="en-US" sz="1200" dirty="0"/>
+              <a:t>https://www.ibm.com/topics/neural-networks</a:t>
+            </a:r>
+          </a:p>
+        </p:txBody>
+      </p:sp>
+      <p:pic>
+        <p:nvPicPr>
+          <p:cNvPr id="18" name="Picture 17" descr="A diagram of a network&#10;&#10;Description automatically generated">
+            <a:extLst>
+              <a:ext uri="{FF2B5EF4-FFF2-40B4-BE49-F238E27FC236}">
+                <a16:creationId xmlns:a16="http://schemas.microsoft.com/office/drawing/2014/main" id="{80B82749-65B7-EC6C-252B-C6D714E6EBFC}"/>
+              </a:ext>
+            </a:extLst>
+          </p:cNvPr>
+          <p:cNvPicPr>
+            <a:picLocks noChangeAspect="1"/>
+          </p:cNvPicPr>
+          <p:nvPr/>
+        </p:nvPicPr>
+        <p:blipFill>
+          <a:blip r:embed="rId4"/>
           <a:stretch>
             <a:fillRect/>
           </a:stretch>
@@ -4855,8 +6327,8 @@
 </p:sld>
 </file>
 
-<file path=ppt/slides/slide3.xml><?xml version="1.0" encoding="utf-8"?>
-<p:sld xmlns:a="http://schemas.openxmlformats.org/drawingml/2006/main" xmlns:r="http://schemas.openxmlformats.org/officeDocument/2006/relationships" xmlns:p="http://schemas.openxmlformats.org/presentationml/2006/main">
+<file path=ppt/slides/slide5.xml><?xml version="1.0" encoding="utf-8"?>
+<p:sld xmlns:a="http://schemas.openxmlformats.org/drawingml/2006/main" xmlns:r="http://schemas.openxmlformats.org/officeDocument/2006/relationships" xmlns:p="http://schemas.openxmlformats.org/presentationml/2006/main" show="0">
   <p:cSld>
     <p:spTree>
       <p:nvGrpSpPr>
@@ -5314,8 +6786,8 @@
 </p:sld>
 </file>
 
-<file path=ppt/slides/slide4.xml><?xml version="1.0" encoding="utf-8"?>
-<p:sld xmlns:a="http://schemas.openxmlformats.org/drawingml/2006/main" xmlns:r="http://schemas.openxmlformats.org/officeDocument/2006/relationships" xmlns:p="http://schemas.openxmlformats.org/presentationml/2006/main">
+<file path=ppt/slides/slide6.xml><?xml version="1.0" encoding="utf-8"?>
+<p:sld xmlns:a="http://schemas.openxmlformats.org/drawingml/2006/main" xmlns:r="http://schemas.openxmlformats.org/officeDocument/2006/relationships" xmlns:p="http://schemas.openxmlformats.org/presentationml/2006/main" show="0">
   <p:cSld>
     <p:spTree>
       <p:nvGrpSpPr>

</xml_diff>